<commit_message>
Make carousel PPTX Canva-import-friendly (drop exotic shapes/emoji)
Replaced rightTriangle shapes, removed emoji glyphs, simplified slide 5
connectors (4 lines instead of dashed loop), and split mixed-color text
runs into separate text frames so Canva's PowerPoint importer accepts it.

Co-Authored-By: Claude Opus 4.7 (1M context) <noreply@anthropic.com>
</commit_message>
<xml_diff>
--- a/linkedin-carousel/NormSafety_LinkedIn_Carousel.pptx
+++ b/linkedin-carousel/NormSafety_LinkedIn_Carousel.pptx
@@ -1397,12 +1397,14 @@
             <a:off x="609905" y="566928"/>
             <a:ext cx="201168" cy="201168"/>
           </a:xfrm>
-          <a:prstGeom prst="rightTriangle">
-            <a:avLst/>
+          <a:prstGeom prst="roundRect">
+            <a:avLst>
+              <a:gd name="adj" fmla="val 18182"/>
+            </a:avLst>
           </a:prstGeom>
           <a:solidFill>
             <a:srgbClr val="5EE7FF">
-              <a:alpha val="20000"/>
+              <a:alpha val="40000"/>
             </a:srgbClr>
           </a:solidFill>
           <a:ln w="12700">
@@ -1483,9 +1485,9 @@
                     <a:alpha val="50000"/>
                   </a:srgbClr>
                 </a:solidFill>
-                <a:latin typeface="JetBrains Mono" pitchFamily="34" charset="0"/>
-                <a:ea typeface="JetBrains Mono" pitchFamily="34" charset="-122"/>
-                <a:cs typeface="JetBrains Mono" pitchFamily="34" charset="-120"/>
+                <a:latin typeface="Consolas" pitchFamily="34" charset="0"/>
+                <a:ea typeface="Consolas" pitchFamily="34" charset="-122"/>
+                <a:cs typeface="Consolas" pitchFamily="34" charset="-120"/>
               </a:rPr>
               <a:t>01 / 06</a:t>
             </a:r>
@@ -1819,10 +1821,32 @@
                 <a:ea typeface="Sora" pitchFamily="34" charset="-122"/>
                 <a:cs typeface="Sora" pitchFamily="34" charset="-120"/>
               </a:rPr>
-              <a:t>levier de </a:t>
+              <a:t>levier de performance ?</a:t>
             </a:r>
             <a:endParaRPr lang="en-US" sz="5600" dirty="0"/>
           </a:p>
+        </p:txBody>
+      </p:sp>
+      <p:sp>
+        <p:nvSpPr>
+          <p:cNvPr id="20" name="Text 18"/>
+          <p:cNvSpPr/>
+          <p:nvPr/>
+        </p:nvSpPr>
+        <p:spPr>
+          <a:xfrm>
+            <a:off x="2301545" y="5394960"/>
+            <a:ext cx="4114800" cy="914400"/>
+          </a:xfrm>
+          <a:prstGeom prst="rect">
+            <a:avLst/>
+          </a:prstGeom>
+          <a:noFill/>
+          <a:ln/>
+        </p:spPr>
+        <p:txBody>
+          <a:bodyPr wrap="square" rtlCol="0" anchor="ctr"/>
+          <a:lstStyle/>
           <a:p>
             <a:pPr indent="0" marL="0">
               <a:buNone/>
@@ -1838,27 +1862,13 @@
               </a:rPr>
               <a:t>performance</a:t>
             </a:r>
-            <a:pPr indent="0" marL="0">
-              <a:buNone/>
-            </a:pPr>
-            <a:r>
-              <a:rPr lang="en-US" sz="5600" b="1" dirty="0">
-                <a:solidFill>
-                  <a:srgbClr val="FFFFFF"/>
-                </a:solidFill>
-                <a:latin typeface="Sora" pitchFamily="34" charset="0"/>
-                <a:ea typeface="Sora" pitchFamily="34" charset="-122"/>
-                <a:cs typeface="Sora" pitchFamily="34" charset="-120"/>
-              </a:rPr>
-              <a:t> ?</a:t>
-            </a:r>
             <a:endParaRPr lang="en-US" sz="5600" dirty="0"/>
           </a:p>
         </p:txBody>
       </p:sp>
       <p:sp>
         <p:nvSpPr>
-          <p:cNvPr id="20" name="Shape 18"/>
+          <p:cNvPr id="21" name="Shape 19"/>
           <p:cNvSpPr/>
           <p:nvPr/>
         </p:nvSpPr>
@@ -1878,7 +1888,7 @@
       </p:sp>
       <p:sp>
         <p:nvSpPr>
-          <p:cNvPr id="21" name="Text 19"/>
+          <p:cNvPr id="22" name="Text 20"/>
           <p:cNvSpPr/>
           <p:nvPr/>
         </p:nvSpPr>
@@ -1934,7 +1944,7 @@
       </p:sp>
       <p:sp>
         <p:nvSpPr>
-          <p:cNvPr id="22" name="Shape 20"/>
+          <p:cNvPr id="23" name="Shape 21"/>
           <p:cNvSpPr/>
           <p:nvPr/>
         </p:nvSpPr>
@@ -1963,7 +1973,7 @@
       </p:sp>
       <p:sp>
         <p:nvSpPr>
-          <p:cNvPr id="23" name="Text 21"/>
+          <p:cNvPr id="24" name="Text 22"/>
           <p:cNvSpPr/>
           <p:nvPr/>
         </p:nvSpPr>
@@ -2109,12 +2119,14 @@
             <a:off x="609905" y="566928"/>
             <a:ext cx="201168" cy="201168"/>
           </a:xfrm>
-          <a:prstGeom prst="rightTriangle">
-            <a:avLst/>
+          <a:prstGeom prst="roundRect">
+            <a:avLst>
+              <a:gd name="adj" fmla="val 18182"/>
+            </a:avLst>
           </a:prstGeom>
           <a:solidFill>
             <a:srgbClr val="5EE7FF">
-              <a:alpha val="20000"/>
+              <a:alpha val="40000"/>
             </a:srgbClr>
           </a:solidFill>
           <a:ln w="12700">
@@ -2195,9 +2207,9 @@
                     <a:alpha val="50000"/>
                   </a:srgbClr>
                 </a:solidFill>
-                <a:latin typeface="JetBrains Mono" pitchFamily="34" charset="0"/>
-                <a:ea typeface="JetBrains Mono" pitchFamily="34" charset="-122"/>
-                <a:cs typeface="JetBrains Mono" pitchFamily="34" charset="-120"/>
+                <a:latin typeface="Consolas" pitchFamily="34" charset="0"/>
+                <a:ea typeface="Consolas" pitchFamily="34" charset="-122"/>
+                <a:cs typeface="Consolas" pitchFamily="34" charset="-120"/>
               </a:rPr>
               <a:t>02 / 06</a:t>
             </a:r>
@@ -2314,10 +2326,32 @@
                 <a:ea typeface="Sora" pitchFamily="34" charset="-122"/>
                 <a:cs typeface="Sora" pitchFamily="34" charset="-120"/>
               </a:rPr>
-              <a:t>trop </a:t>
+              <a:t>trop fragmentée.</a:t>
             </a:r>
             <a:endParaRPr lang="en-US" sz="4400" dirty="0"/>
           </a:p>
+        </p:txBody>
+      </p:sp>
+      <p:sp>
+        <p:nvSpPr>
+          <p:cNvPr id="11" name="Text 9"/>
+          <p:cNvSpPr/>
+          <p:nvPr/>
+        </p:nvSpPr>
+        <p:spPr>
+          <a:xfrm>
+            <a:off x="2255825" y="3200400"/>
+            <a:ext cx="5486400" cy="822960"/>
+          </a:xfrm>
+          <a:prstGeom prst="rect">
+            <a:avLst/>
+          </a:prstGeom>
+          <a:noFill/>
+          <a:ln/>
+        </p:spPr>
+        <p:txBody>
+          <a:bodyPr wrap="square" rtlCol="0" anchor="ctr"/>
+          <a:lstStyle/>
           <a:p>
             <a:pPr indent="0" marL="0">
               <a:buNone/>
@@ -2331,21 +2365,7 @@
                 <a:ea typeface="Sora" pitchFamily="34" charset="-122"/>
                 <a:cs typeface="Sora" pitchFamily="34" charset="-120"/>
               </a:rPr>
-              <a:t>fragmentée</a:t>
-            </a:r>
-            <a:pPr indent="0" marL="0">
-              <a:buNone/>
-            </a:pPr>
-            <a:r>
-              <a:rPr lang="en-US" sz="4400" b="1" dirty="0">
-                <a:solidFill>
-                  <a:srgbClr val="FFFFFF"/>
-                </a:solidFill>
-                <a:latin typeface="Sora" pitchFamily="34" charset="0"/>
-                <a:ea typeface="Sora" pitchFamily="34" charset="-122"/>
-                <a:cs typeface="Sora" pitchFamily="34" charset="-120"/>
-              </a:rPr>
-              <a:t>.</a:t>
+              <a:t>fragmentée.</a:t>
             </a:r>
             <a:endParaRPr lang="en-US" sz="4400" dirty="0"/>
           </a:p>
@@ -2353,7 +2373,7 @@
       </p:sp>
       <p:sp>
         <p:nvSpPr>
-          <p:cNvPr id="11" name="Shape 9"/>
+          <p:cNvPr id="12" name="Shape 10"/>
           <p:cNvSpPr/>
           <p:nvPr/>
         </p:nvSpPr>
@@ -2373,7 +2393,7 @@
       </p:sp>
       <p:sp>
         <p:nvSpPr>
-          <p:cNvPr id="12" name="Shape 10"/>
+          <p:cNvPr id="13" name="Shape 11"/>
           <p:cNvSpPr/>
           <p:nvPr/>
         </p:nvSpPr>
@@ -2404,7 +2424,7 @@
       </p:sp>
       <p:sp>
         <p:nvSpPr>
-          <p:cNvPr id="13" name="Shape 11"/>
+          <p:cNvPr id="14" name="Shape 12"/>
           <p:cNvSpPr/>
           <p:nvPr/>
         </p:nvSpPr>
@@ -2433,7 +2453,7 @@
       </p:sp>
       <p:sp>
         <p:nvSpPr>
-          <p:cNvPr id="14" name="Text 12"/>
+          <p:cNvPr id="15" name="Text 13"/>
           <p:cNvSpPr/>
           <p:nvPr/>
         </p:nvSpPr>
@@ -2462,9 +2482,9 @@
                     <a:alpha val="50000"/>
                   </a:srgbClr>
                 </a:solidFill>
-                <a:latin typeface="JetBrains Mono" pitchFamily="34" charset="0"/>
-                <a:ea typeface="JetBrains Mono" pitchFamily="34" charset="-122"/>
-                <a:cs typeface="JetBrains Mono" pitchFamily="34" charset="-120"/>
+                <a:latin typeface="Consolas" pitchFamily="34" charset="0"/>
+                <a:ea typeface="Consolas" pitchFamily="34" charset="-122"/>
+                <a:cs typeface="Consolas" pitchFamily="34" charset="-120"/>
               </a:rPr>
               <a:t>01</a:t>
             </a:r>
@@ -2474,7 +2494,7 @@
       </p:sp>
       <p:sp>
         <p:nvSpPr>
-          <p:cNvPr id="15" name="Text 13"/>
+          <p:cNvPr id="16" name="Text 14"/>
           <p:cNvSpPr/>
           <p:nvPr/>
         </p:nvSpPr>
@@ -2530,7 +2550,7 @@
       </p:sp>
       <p:sp>
         <p:nvSpPr>
-          <p:cNvPr id="16" name="Shape 14"/>
+          <p:cNvPr id="17" name="Shape 15"/>
           <p:cNvSpPr/>
           <p:nvPr/>
         </p:nvSpPr>
@@ -2561,7 +2581,7 @@
       </p:sp>
       <p:sp>
         <p:nvSpPr>
-          <p:cNvPr id="17" name="Shape 15"/>
+          <p:cNvPr id="18" name="Shape 16"/>
           <p:cNvSpPr/>
           <p:nvPr/>
         </p:nvSpPr>
@@ -2590,7 +2610,7 @@
       </p:sp>
       <p:sp>
         <p:nvSpPr>
-          <p:cNvPr id="18" name="Text 16"/>
+          <p:cNvPr id="19" name="Text 17"/>
           <p:cNvSpPr/>
           <p:nvPr/>
         </p:nvSpPr>
@@ -2619,9 +2639,9 @@
                     <a:alpha val="50000"/>
                   </a:srgbClr>
                 </a:solidFill>
-                <a:latin typeface="JetBrains Mono" pitchFamily="34" charset="0"/>
-                <a:ea typeface="JetBrains Mono" pitchFamily="34" charset="-122"/>
-                <a:cs typeface="JetBrains Mono" pitchFamily="34" charset="-120"/>
+                <a:latin typeface="Consolas" pitchFamily="34" charset="0"/>
+                <a:ea typeface="Consolas" pitchFamily="34" charset="-122"/>
+                <a:cs typeface="Consolas" pitchFamily="34" charset="-120"/>
               </a:rPr>
               <a:t>02</a:t>
             </a:r>
@@ -2631,7 +2651,7 @@
       </p:sp>
       <p:sp>
         <p:nvSpPr>
-          <p:cNvPr id="19" name="Text 17"/>
+          <p:cNvPr id="20" name="Text 18"/>
           <p:cNvSpPr/>
           <p:nvPr/>
         </p:nvSpPr>
@@ -2687,7 +2707,7 @@
       </p:sp>
       <p:sp>
         <p:nvSpPr>
-          <p:cNvPr id="20" name="Shape 18"/>
+          <p:cNvPr id="21" name="Shape 19"/>
           <p:cNvSpPr/>
           <p:nvPr/>
         </p:nvSpPr>
@@ -2718,7 +2738,7 @@
       </p:sp>
       <p:sp>
         <p:nvSpPr>
-          <p:cNvPr id="21" name="Shape 19"/>
+          <p:cNvPr id="22" name="Shape 20"/>
           <p:cNvSpPr/>
           <p:nvPr/>
         </p:nvSpPr>
@@ -2747,7 +2767,7 @@
       </p:sp>
       <p:sp>
         <p:nvSpPr>
-          <p:cNvPr id="22" name="Text 20"/>
+          <p:cNvPr id="23" name="Text 21"/>
           <p:cNvSpPr/>
           <p:nvPr/>
         </p:nvSpPr>
@@ -2776,9 +2796,9 @@
                     <a:alpha val="50000"/>
                   </a:srgbClr>
                 </a:solidFill>
-                <a:latin typeface="JetBrains Mono" pitchFamily="34" charset="0"/>
-                <a:ea typeface="JetBrains Mono" pitchFamily="34" charset="-122"/>
-                <a:cs typeface="JetBrains Mono" pitchFamily="34" charset="-120"/>
+                <a:latin typeface="Consolas" pitchFamily="34" charset="0"/>
+                <a:ea typeface="Consolas" pitchFamily="34" charset="-122"/>
+                <a:cs typeface="Consolas" pitchFamily="34" charset="-120"/>
               </a:rPr>
               <a:t>03</a:t>
             </a:r>
@@ -2788,7 +2808,7 @@
       </p:sp>
       <p:sp>
         <p:nvSpPr>
-          <p:cNvPr id="23" name="Text 21"/>
+          <p:cNvPr id="24" name="Text 22"/>
           <p:cNvSpPr/>
           <p:nvPr/>
         </p:nvSpPr>
@@ -2844,7 +2864,7 @@
       </p:sp>
       <p:sp>
         <p:nvSpPr>
-          <p:cNvPr id="24" name="Shape 22"/>
+          <p:cNvPr id="25" name="Shape 23"/>
           <p:cNvSpPr/>
           <p:nvPr/>
         </p:nvSpPr>
@@ -2875,7 +2895,7 @@
       </p:sp>
       <p:sp>
         <p:nvSpPr>
-          <p:cNvPr id="25" name="Shape 23"/>
+          <p:cNvPr id="26" name="Shape 24"/>
           <p:cNvSpPr/>
           <p:nvPr/>
         </p:nvSpPr>
@@ -2904,7 +2924,7 @@
       </p:sp>
       <p:sp>
         <p:nvSpPr>
-          <p:cNvPr id="26" name="Text 24"/>
+          <p:cNvPr id="27" name="Text 25"/>
           <p:cNvSpPr/>
           <p:nvPr/>
         </p:nvSpPr>
@@ -2933,9 +2953,9 @@
                     <a:alpha val="50000"/>
                   </a:srgbClr>
                 </a:solidFill>
-                <a:latin typeface="JetBrains Mono" pitchFamily="34" charset="0"/>
-                <a:ea typeface="JetBrains Mono" pitchFamily="34" charset="-122"/>
-                <a:cs typeface="JetBrains Mono" pitchFamily="34" charset="-120"/>
+                <a:latin typeface="Consolas" pitchFamily="34" charset="0"/>
+                <a:ea typeface="Consolas" pitchFamily="34" charset="-122"/>
+                <a:cs typeface="Consolas" pitchFamily="34" charset="-120"/>
               </a:rPr>
               <a:t>04</a:t>
             </a:r>
@@ -2945,7 +2965,7 @@
       </p:sp>
       <p:sp>
         <p:nvSpPr>
-          <p:cNvPr id="27" name="Text 25"/>
+          <p:cNvPr id="28" name="Text 26"/>
           <p:cNvSpPr/>
           <p:nvPr/>
         </p:nvSpPr>
@@ -3001,7 +3021,7 @@
       </p:sp>
       <p:sp>
         <p:nvSpPr>
-          <p:cNvPr id="28" name="Shape 26"/>
+          <p:cNvPr id="29" name="Shape 27"/>
           <p:cNvSpPr/>
           <p:nvPr/>
         </p:nvSpPr>
@@ -3030,7 +3050,7 @@
       </p:sp>
       <p:sp>
         <p:nvSpPr>
-          <p:cNvPr id="29" name="Text 27"/>
+          <p:cNvPr id="30" name="Text 28"/>
           <p:cNvSpPr/>
           <p:nvPr/>
         </p:nvSpPr>
@@ -3176,12 +3196,14 @@
             <a:off x="609905" y="566928"/>
             <a:ext cx="201168" cy="201168"/>
           </a:xfrm>
-          <a:prstGeom prst="rightTriangle">
-            <a:avLst/>
+          <a:prstGeom prst="roundRect">
+            <a:avLst>
+              <a:gd name="adj" fmla="val 18182"/>
+            </a:avLst>
           </a:prstGeom>
           <a:solidFill>
             <a:srgbClr val="5EE7FF">
-              <a:alpha val="20000"/>
+              <a:alpha val="40000"/>
             </a:srgbClr>
           </a:solidFill>
           <a:ln w="12700">
@@ -3262,9 +3284,9 @@
                     <a:alpha val="50000"/>
                   </a:srgbClr>
                 </a:solidFill>
-                <a:latin typeface="JetBrains Mono" pitchFamily="34" charset="0"/>
-                <a:ea typeface="JetBrains Mono" pitchFamily="34" charset="-122"/>
-                <a:cs typeface="JetBrains Mono" pitchFamily="34" charset="-120"/>
+                <a:latin typeface="Consolas" pitchFamily="34" charset="0"/>
+                <a:ea typeface="Consolas" pitchFamily="34" charset="-122"/>
+                <a:cs typeface="Consolas" pitchFamily="34" charset="-120"/>
               </a:rPr>
               <a:t>03 / 06</a:t>
             </a:r>
@@ -3364,24 +3386,28 @@
                 <a:ea typeface="Sora" pitchFamily="34" charset="-122"/>
                 <a:cs typeface="Sora" pitchFamily="34" charset="-120"/>
               </a:rPr>
-              <a:t>Une approche
-</a:t>
-            </a:r>
+              <a:t>Une approche</a:t>
+            </a:r>
+            <a:endParaRPr lang="en-US" sz="3800" dirty="0"/>
+          </a:p>
+          <a:p>
             <a:pPr indent="0" marL="0">
               <a:buNone/>
             </a:pPr>
             <a:r>
               <a:rPr lang="en-US" sz="3800" b="1" dirty="0">
                 <a:solidFill>
-                  <a:srgbClr val="5EE7FF"/>
+                  <a:srgbClr val="FFFFFF"/>
                 </a:solidFill>
                 <a:latin typeface="Sora" pitchFamily="34" charset="0"/>
                 <a:ea typeface="Sora" pitchFamily="34" charset="-122"/>
                 <a:cs typeface="Sora" pitchFamily="34" charset="-120"/>
               </a:rPr>
-              <a:t>centralisée
-</a:t>
-            </a:r>
+              <a:t>centralisée</a:t>
+            </a:r>
+            <a:endParaRPr lang="en-US" sz="3800" dirty="0"/>
+          </a:p>
+          <a:p>
             <a:pPr indent="0" marL="0">
               <a:buNone/>
             </a:pPr>
@@ -3402,7 +3428,46 @@
       </p:sp>
       <p:sp>
         <p:nvSpPr>
-          <p:cNvPr id="11" name="Shape 9"/>
+          <p:cNvPr id="11" name="Text 9"/>
+          <p:cNvSpPr/>
+          <p:nvPr/>
+        </p:nvSpPr>
+        <p:spPr>
+          <a:xfrm>
+            <a:off x="609905" y="3474720"/>
+            <a:ext cx="4114800" cy="777240"/>
+          </a:xfrm>
+          <a:prstGeom prst="rect">
+            <a:avLst/>
+          </a:prstGeom>
+          <a:noFill/>
+          <a:ln/>
+        </p:spPr>
+        <p:txBody>
+          <a:bodyPr wrap="square" rtlCol="0" anchor="ctr"/>
+          <a:lstStyle/>
+          <a:p>
+            <a:pPr indent="0" marL="0">
+              <a:buNone/>
+            </a:pPr>
+            <a:r>
+              <a:rPr lang="en-US" sz="3800" b="1" dirty="0">
+                <a:solidFill>
+                  <a:srgbClr val="5EE7FF"/>
+                </a:solidFill>
+                <a:latin typeface="Sora" pitchFamily="34" charset="0"/>
+                <a:ea typeface="Sora" pitchFamily="34" charset="-122"/>
+                <a:cs typeface="Sora" pitchFamily="34" charset="-120"/>
+              </a:rPr>
+              <a:t>centralisée</a:t>
+            </a:r>
+            <a:endParaRPr lang="en-US" sz="3800" dirty="0"/>
+          </a:p>
+        </p:txBody>
+      </p:sp>
+      <p:sp>
+        <p:nvSpPr>
+          <p:cNvPr id="12" name="Shape 10"/>
           <p:cNvSpPr/>
           <p:nvPr/>
         </p:nvSpPr>
@@ -3422,7 +3487,7 @@
       </p:sp>
       <p:sp>
         <p:nvSpPr>
-          <p:cNvPr id="12" name="Text 10"/>
+          <p:cNvPr id="13" name="Text 11"/>
           <p:cNvSpPr/>
           <p:nvPr/>
         </p:nvSpPr>
@@ -3461,7 +3526,7 @@
       </p:sp>
       <p:sp>
         <p:nvSpPr>
-          <p:cNvPr id="13" name="Shape 11"/>
+          <p:cNvPr id="14" name="Shape 12"/>
           <p:cNvSpPr/>
           <p:nvPr/>
         </p:nvSpPr>
@@ -3492,7 +3557,7 @@
       </p:sp>
       <p:sp>
         <p:nvSpPr>
-          <p:cNvPr id="14" name="Text 12"/>
+          <p:cNvPr id="15" name="Text 13"/>
           <p:cNvSpPr/>
           <p:nvPr/>
         </p:nvSpPr>
@@ -3525,7 +3590,7 @@
                 <a:ea typeface="Inter" pitchFamily="34" charset="-122"/>
                 <a:cs typeface="Inter" pitchFamily="34" charset="-120"/>
               </a:rPr>
-              <a:t>Dashboard SST</a:t>
+              <a:t>DASHBOARD SST</a:t>
             </a:r>
             <a:endParaRPr lang="en-US" sz="900" dirty="0"/>
           </a:p>
@@ -3533,7 +3598,7 @@
       </p:sp>
       <p:sp>
         <p:nvSpPr>
-          <p:cNvPr id="15" name="Shape 13"/>
+          <p:cNvPr id="16" name="Shape 14"/>
           <p:cNvSpPr/>
           <p:nvPr/>
         </p:nvSpPr>
@@ -3555,7 +3620,7 @@
       </p:sp>
       <p:sp>
         <p:nvSpPr>
-          <p:cNvPr id="16" name="Shape 14"/>
+          <p:cNvPr id="17" name="Shape 15"/>
           <p:cNvSpPr/>
           <p:nvPr/>
         </p:nvSpPr>
@@ -3577,7 +3642,7 @@
       </p:sp>
       <p:sp>
         <p:nvSpPr>
-          <p:cNvPr id="17" name="Shape 15"/>
+          <p:cNvPr id="18" name="Shape 16"/>
           <p:cNvSpPr/>
           <p:nvPr/>
         </p:nvSpPr>
@@ -3599,7 +3664,7 @@
       </p:sp>
       <p:sp>
         <p:nvSpPr>
-          <p:cNvPr id="18" name="Shape 16"/>
+          <p:cNvPr id="19" name="Shape 17"/>
           <p:cNvSpPr/>
           <p:nvPr/>
         </p:nvSpPr>
@@ -3630,7 +3695,7 @@
       </p:sp>
       <p:sp>
         <p:nvSpPr>
-          <p:cNvPr id="19" name="Text 17"/>
+          <p:cNvPr id="20" name="Text 18"/>
           <p:cNvSpPr/>
           <p:nvPr/>
         </p:nvSpPr>
@@ -3671,14 +3736,14 @@
       </p:sp>
       <p:sp>
         <p:nvSpPr>
-          <p:cNvPr id="20" name="Text 18"/>
+          <p:cNvPr id="21" name="Text 19"/>
           <p:cNvSpPr/>
           <p:nvPr/>
         </p:nvSpPr>
         <p:spPr>
           <a:xfrm>
             <a:off x="5242255" y="3429000"/>
-            <a:ext cx="3657600" cy="914400"/>
+            <a:ext cx="1828800" cy="914400"/>
           </a:xfrm>
           <a:prstGeom prst="rect">
             <a:avLst/>
@@ -3704,6 +3769,31 @@
               </a:rPr>
               <a:t>94</a:t>
             </a:r>
+            <a:endParaRPr lang="en-US" sz="5600" dirty="0"/>
+          </a:p>
+        </p:txBody>
+      </p:sp>
+      <p:sp>
+        <p:nvSpPr>
+          <p:cNvPr id="22" name="Text 20"/>
+          <p:cNvSpPr/>
+          <p:nvPr/>
+        </p:nvSpPr>
+        <p:spPr>
+          <a:xfrm>
+            <a:off x="6430975" y="3657600"/>
+            <a:ext cx="914400" cy="548640"/>
+          </a:xfrm>
+          <a:prstGeom prst="rect">
+            <a:avLst/>
+          </a:prstGeom>
+          <a:noFill/>
+          <a:ln/>
+        </p:spPr>
+        <p:txBody>
+          <a:bodyPr wrap="square" rtlCol="0" anchor="ctr"/>
+          <a:lstStyle/>
+          <a:p>
             <a:pPr indent="0" marL="0">
               <a:buNone/>
             </a:pPr>
@@ -3718,13 +3808,13 @@
               </a:rPr>
               <a:t>%</a:t>
             </a:r>
-            <a:endParaRPr lang="en-US" sz="5600" dirty="0"/>
-          </a:p>
-        </p:txBody>
-      </p:sp>
-      <p:sp>
-        <p:nvSpPr>
-          <p:cNvPr id="21" name="Text 19"/>
+            <a:endParaRPr lang="en-US" sz="2800" dirty="0"/>
+          </a:p>
+        </p:txBody>
+      </p:sp>
+      <p:sp>
+        <p:nvSpPr>
+          <p:cNvPr id="23" name="Text 21"/>
           <p:cNvSpPr/>
           <p:nvPr/>
         </p:nvSpPr>
@@ -3755,7 +3845,7 @@
                 <a:ea typeface="Inter" pitchFamily="34" charset="-122"/>
                 <a:cs typeface="Inter" pitchFamily="34" charset="-120"/>
               </a:rPr>
-              <a:t>↗  +12 % vs trimestre précédent</a:t>
+              <a:t>+12 % vs trimestre précédent</a:t>
             </a:r>
             <a:endParaRPr lang="en-US" sz="1100" dirty="0"/>
           </a:p>
@@ -3763,7 +3853,7 @@
       </p:sp>
       <p:sp>
         <p:nvSpPr>
-          <p:cNvPr id="22" name="Shape 20"/>
+          <p:cNvPr id="24" name="Shape 22"/>
           <p:cNvSpPr/>
           <p:nvPr/>
         </p:nvSpPr>
@@ -3794,7 +3884,7 @@
       </p:sp>
       <p:sp>
         <p:nvSpPr>
-          <p:cNvPr id="23" name="Text 21"/>
+          <p:cNvPr id="25" name="Text 23"/>
           <p:cNvSpPr/>
           <p:nvPr/>
         </p:nvSpPr>
@@ -3835,7 +3925,7 @@
       </p:sp>
       <p:sp>
         <p:nvSpPr>
-          <p:cNvPr id="24" name="Shape 22"/>
+          <p:cNvPr id="26" name="Shape 24"/>
           <p:cNvSpPr/>
           <p:nvPr/>
         </p:nvSpPr>
@@ -3857,7 +3947,7 @@
       </p:sp>
       <p:sp>
         <p:nvSpPr>
-          <p:cNvPr id="25" name="Shape 23"/>
+          <p:cNvPr id="27" name="Shape 25"/>
           <p:cNvSpPr/>
           <p:nvPr/>
         </p:nvSpPr>
@@ -3879,7 +3969,7 @@
       </p:sp>
       <p:sp>
         <p:nvSpPr>
-          <p:cNvPr id="26" name="Shape 24"/>
+          <p:cNvPr id="28" name="Shape 26"/>
           <p:cNvSpPr/>
           <p:nvPr/>
         </p:nvSpPr>
@@ -3899,7 +3989,7 @@
       </p:sp>
       <p:sp>
         <p:nvSpPr>
-          <p:cNvPr id="27" name="Shape 25"/>
+          <p:cNvPr id="29" name="Shape 27"/>
           <p:cNvSpPr/>
           <p:nvPr/>
         </p:nvSpPr>
@@ -3921,7 +4011,7 @@
       </p:sp>
       <p:sp>
         <p:nvSpPr>
-          <p:cNvPr id="28" name="Shape 26"/>
+          <p:cNvPr id="30" name="Shape 28"/>
           <p:cNvSpPr/>
           <p:nvPr/>
         </p:nvSpPr>
@@ -3943,7 +4033,7 @@
       </p:sp>
       <p:sp>
         <p:nvSpPr>
-          <p:cNvPr id="29" name="Shape 27"/>
+          <p:cNvPr id="31" name="Shape 29"/>
           <p:cNvSpPr/>
           <p:nvPr/>
         </p:nvSpPr>
@@ -3965,7 +4055,7 @@
       </p:sp>
       <p:sp>
         <p:nvSpPr>
-          <p:cNvPr id="30" name="Shape 28"/>
+          <p:cNvPr id="32" name="Shape 30"/>
           <p:cNvSpPr/>
           <p:nvPr/>
         </p:nvSpPr>
@@ -3996,14 +4086,14 @@
       </p:sp>
       <p:sp>
         <p:nvSpPr>
-          <p:cNvPr id="31" name="Shape 29"/>
-          <p:cNvSpPr/>
-          <p:nvPr/>
-        </p:nvSpPr>
-        <p:spPr>
-          <a:xfrm>
-            <a:off x="5196535" y="8092440"/>
-            <a:ext cx="548640" cy="-182880"/>
+          <p:cNvPr id="33" name="Shape 31"/>
+          <p:cNvSpPr/>
+          <p:nvPr/>
+        </p:nvSpPr>
+        <p:spPr>
+          <a:xfrm>
+            <a:off x="5242255" y="7859268"/>
+            <a:ext cx="982980" cy="-192024"/>
           </a:xfrm>
           <a:prstGeom prst="line">
             <a:avLst/>
@@ -4019,14 +4109,14 @@
       </p:sp>
       <p:sp>
         <p:nvSpPr>
-          <p:cNvPr id="32" name="Shape 30"/>
-          <p:cNvSpPr/>
-          <p:nvPr/>
-        </p:nvSpPr>
-        <p:spPr>
-          <a:xfrm>
-            <a:off x="5745175" y="7909560"/>
-            <a:ext cx="548640" cy="91440"/>
+          <p:cNvPr id="34" name="Shape 32"/>
+          <p:cNvSpPr/>
+          <p:nvPr/>
+        </p:nvSpPr>
+        <p:spPr>
+          <a:xfrm>
+            <a:off x="6225235" y="7667244"/>
+            <a:ext cx="982980" cy="64008"/>
           </a:xfrm>
           <a:prstGeom prst="line">
             <a:avLst/>
@@ -4042,14 +4132,14 @@
       </p:sp>
       <p:sp>
         <p:nvSpPr>
-          <p:cNvPr id="33" name="Shape 31"/>
-          <p:cNvSpPr/>
-          <p:nvPr/>
-        </p:nvSpPr>
-        <p:spPr>
-          <a:xfrm>
-            <a:off x="6293815" y="8001000"/>
-            <a:ext cx="548640" cy="-320040"/>
+          <p:cNvPr id="35" name="Shape 33"/>
+          <p:cNvSpPr/>
+          <p:nvPr/>
+        </p:nvSpPr>
+        <p:spPr>
+          <a:xfrm>
+            <a:off x="7208215" y="7731252"/>
+            <a:ext cx="982980" cy="-224028"/>
           </a:xfrm>
           <a:prstGeom prst="line">
             <a:avLst/>
@@ -4065,14 +4155,14 @@
       </p:sp>
       <p:sp>
         <p:nvSpPr>
-          <p:cNvPr id="34" name="Shape 32"/>
-          <p:cNvSpPr/>
-          <p:nvPr/>
-        </p:nvSpPr>
-        <p:spPr>
-          <a:xfrm>
-            <a:off x="6842455" y="7680960"/>
-            <a:ext cx="548640" cy="91440"/>
+          <p:cNvPr id="36" name="Shape 34"/>
+          <p:cNvSpPr/>
+          <p:nvPr/>
+        </p:nvSpPr>
+        <p:spPr>
+          <a:xfrm>
+            <a:off x="8191195" y="7507224"/>
+            <a:ext cx="982980" cy="-128016"/>
           </a:xfrm>
           <a:prstGeom prst="line">
             <a:avLst/>
@@ -4088,76 +4178,7 @@
       </p:sp>
       <p:sp>
         <p:nvSpPr>
-          <p:cNvPr id="35" name="Shape 33"/>
-          <p:cNvSpPr/>
-          <p:nvPr/>
-        </p:nvSpPr>
-        <p:spPr>
-          <a:xfrm>
-            <a:off x="7391095" y="7772400"/>
-            <a:ext cx="548640" cy="-228600"/>
-          </a:xfrm>
-          <a:prstGeom prst="line">
-            <a:avLst/>
-          </a:prstGeom>
-          <a:noFill/>
-          <a:ln w="19050">
-            <a:solidFill>
-              <a:srgbClr val="5EE7FF"/>
-            </a:solidFill>
-            <a:prstDash val="solid"/>
-          </a:ln>
-        </p:spPr>
-      </p:sp>
-      <p:sp>
-        <p:nvSpPr>
-          <p:cNvPr id="36" name="Shape 34"/>
-          <p:cNvSpPr/>
-          <p:nvPr/>
-        </p:nvSpPr>
-        <p:spPr>
-          <a:xfrm>
-            <a:off x="7939735" y="7543800"/>
-            <a:ext cx="548640" cy="137160"/>
-          </a:xfrm>
-          <a:prstGeom prst="line">
-            <a:avLst/>
-          </a:prstGeom>
-          <a:noFill/>
-          <a:ln w="19050">
-            <a:solidFill>
-              <a:srgbClr val="5EE7FF"/>
-            </a:solidFill>
-            <a:prstDash val="solid"/>
-          </a:ln>
-        </p:spPr>
-      </p:sp>
-      <p:sp>
-        <p:nvSpPr>
           <p:cNvPr id="37" name="Shape 35"/>
-          <p:cNvSpPr/>
-          <p:nvPr/>
-        </p:nvSpPr>
-        <p:spPr>
-          <a:xfrm>
-            <a:off x="8488375" y="7680960"/>
-            <a:ext cx="548640" cy="-228600"/>
-          </a:xfrm>
-          <a:prstGeom prst="line">
-            <a:avLst/>
-          </a:prstGeom>
-          <a:noFill/>
-          <a:ln w="19050">
-            <a:solidFill>
-              <a:srgbClr val="5EE7FF"/>
-            </a:solidFill>
-            <a:prstDash val="solid"/>
-          </a:ln>
-        </p:spPr>
-      </p:sp>
-      <p:sp>
-        <p:nvSpPr>
-          <p:cNvPr id="38" name="Shape 36"/>
           <p:cNvSpPr/>
           <p:nvPr/>
         </p:nvSpPr>
@@ -4186,7 +4207,7 @@
       </p:sp>
       <p:sp>
         <p:nvSpPr>
-          <p:cNvPr id="39" name="Text 37"/>
+          <p:cNvPr id="38" name="Text 36"/>
           <p:cNvSpPr/>
           <p:nvPr/>
         </p:nvSpPr>
@@ -4332,12 +4353,14 @@
             <a:off x="609905" y="566928"/>
             <a:ext cx="201168" cy="201168"/>
           </a:xfrm>
-          <a:prstGeom prst="rightTriangle">
-            <a:avLst/>
+          <a:prstGeom prst="roundRect">
+            <a:avLst>
+              <a:gd name="adj" fmla="val 18182"/>
+            </a:avLst>
           </a:prstGeom>
           <a:solidFill>
             <a:srgbClr val="5EE7FF">
-              <a:alpha val="20000"/>
+              <a:alpha val="40000"/>
             </a:srgbClr>
           </a:solidFill>
           <a:ln w="12700">
@@ -4418,9 +4441,9 @@
                     <a:alpha val="50000"/>
                   </a:srgbClr>
                 </a:solidFill>
-                <a:latin typeface="JetBrains Mono" pitchFamily="34" charset="0"/>
-                <a:ea typeface="JetBrains Mono" pitchFamily="34" charset="-122"/>
-                <a:cs typeface="JetBrains Mono" pitchFamily="34" charset="-120"/>
+                <a:latin typeface="Consolas" pitchFamily="34" charset="0"/>
+                <a:ea typeface="Consolas" pitchFamily="34" charset="-122"/>
+                <a:cs typeface="Consolas" pitchFamily="34" charset="-120"/>
               </a:rPr>
               <a:t>04 / 06</a:t>
             </a:r>
@@ -4500,36 +4523,63 @@
                 <a:ea typeface="Sora" pitchFamily="34" charset="-122"/>
                 <a:cs typeface="Sora" pitchFamily="34" charset="-120"/>
               </a:rPr>
-              <a:t>Pensé pour les
-</a:t>
-            </a:r>
+              <a:t>Pensé pour les</a:t>
+            </a:r>
+            <a:endParaRPr lang="en-US" sz="4800" dirty="0"/>
+          </a:p>
+          <a:p>
             <a:pPr algn="ctr" indent="0" marL="0">
               <a:buNone/>
             </a:pPr>
             <a:r>
               <a:rPr lang="en-US" sz="4800" b="1" dirty="0">
                 <a:solidFill>
-                  <a:srgbClr val="5EE7FF"/>
+                  <a:srgbClr val="FFFFFF"/>
                 </a:solidFill>
                 <a:latin typeface="Sora" pitchFamily="34" charset="0"/>
                 <a:ea typeface="Sora" pitchFamily="34" charset="-122"/>
                 <a:cs typeface="Sora" pitchFamily="34" charset="-120"/>
               </a:rPr>
-              <a:t>acteurs clés</a:t>
-            </a:r>
+              <a:t>acteurs clés.</a:t>
+            </a:r>
+            <a:endParaRPr lang="en-US" sz="4800" dirty="0"/>
+          </a:p>
+        </p:txBody>
+      </p:sp>
+      <p:sp>
+        <p:nvSpPr>
+          <p:cNvPr id="10" name="Text 8"/>
+          <p:cNvSpPr/>
+          <p:nvPr/>
+        </p:nvSpPr>
+        <p:spPr>
+          <a:xfrm>
+            <a:off x="609905" y="4160520"/>
+            <a:ext cx="9067190" cy="914400"/>
+          </a:xfrm>
+          <a:prstGeom prst="rect">
+            <a:avLst/>
+          </a:prstGeom>
+          <a:noFill/>
+          <a:ln/>
+        </p:spPr>
+        <p:txBody>
+          <a:bodyPr wrap="square" rtlCol="0" anchor="ctr"/>
+          <a:lstStyle/>
+          <a:p>
             <a:pPr algn="ctr" indent="0" marL="0">
               <a:buNone/>
             </a:pPr>
             <a:r>
               <a:rPr lang="en-US" sz="4800" b="1" dirty="0">
                 <a:solidFill>
-                  <a:srgbClr val="FFFFFF"/>
+                  <a:srgbClr val="5EE7FF"/>
                 </a:solidFill>
                 <a:latin typeface="Sora" pitchFamily="34" charset="0"/>
                 <a:ea typeface="Sora" pitchFamily="34" charset="-122"/>
                 <a:cs typeface="Sora" pitchFamily="34" charset="-120"/>
               </a:rPr>
-              <a:t>.</a:t>
+              <a:t>acteurs clés.</a:t>
             </a:r>
             <a:endParaRPr lang="en-US" sz="4800" dirty="0"/>
           </a:p>
@@ -4537,7 +4587,7 @@
       </p:sp>
       <p:sp>
         <p:nvSpPr>
-          <p:cNvPr id="10" name="Shape 8"/>
+          <p:cNvPr id="11" name="Shape 9"/>
           <p:cNvSpPr/>
           <p:nvPr/>
         </p:nvSpPr>
@@ -4557,7 +4607,7 @@
       </p:sp>
       <p:sp>
         <p:nvSpPr>
-          <p:cNvPr id="11" name="Shape 9"/>
+          <p:cNvPr id="12" name="Shape 10"/>
           <p:cNvSpPr/>
           <p:nvPr/>
         </p:nvSpPr>
@@ -4588,7 +4638,7 @@
       </p:sp>
       <p:sp>
         <p:nvSpPr>
-          <p:cNvPr id="12" name="Shape 10"/>
+          <p:cNvPr id="13" name="Shape 11"/>
           <p:cNvSpPr/>
           <p:nvPr/>
         </p:nvSpPr>
@@ -4617,14 +4667,36 @@
       </p:sp>
       <p:sp>
         <p:nvSpPr>
-          <p:cNvPr id="13" name="Text 11"/>
-          <p:cNvSpPr/>
-          <p:nvPr/>
-        </p:nvSpPr>
-        <p:spPr>
-          <a:xfrm>
-            <a:off x="1450543" y="7498080"/>
-            <a:ext cx="1188720" cy="1005840"/>
+          <p:cNvPr id="14" name="Shape 12"/>
+          <p:cNvSpPr/>
+          <p:nvPr/>
+        </p:nvSpPr>
+        <p:spPr>
+          <a:xfrm>
+            <a:off x="1862023" y="7818120"/>
+            <a:ext cx="365760" cy="365760"/>
+          </a:xfrm>
+          <a:prstGeom prst="ellipse">
+            <a:avLst/>
+          </a:prstGeom>
+          <a:solidFill>
+            <a:srgbClr val="5EE7FF">
+              <a:alpha val="50000"/>
+            </a:srgbClr>
+          </a:solidFill>
+          <a:ln/>
+        </p:spPr>
+      </p:sp>
+      <p:sp>
+        <p:nvSpPr>
+          <p:cNvPr id="15" name="Text 13"/>
+          <p:cNvSpPr/>
+          <p:nvPr/>
+        </p:nvSpPr>
+        <p:spPr>
+          <a:xfrm>
+            <a:off x="884225" y="8869680"/>
+            <a:ext cx="2321357" cy="1097280"/>
           </a:xfrm>
           <a:prstGeom prst="rect">
             <a:avLst/>
@@ -4640,40 +4712,18 @@
               <a:buNone/>
             </a:pPr>
             <a:r>
-              <a:rPr lang="en-US" sz="3600" b="1" dirty="0">
-                <a:solidFill>
-                  <a:srgbClr val="5EE7FF"/>
+              <a:rPr lang="en-US" sz="2200" b="1" dirty="0">
+                <a:solidFill>
+                  <a:srgbClr val="FFFFFF"/>
                 </a:solidFill>
                 <a:latin typeface="Sora" pitchFamily="34" charset="0"/>
                 <a:ea typeface="Sora" pitchFamily="34" charset="-122"/>
                 <a:cs typeface="Sora" pitchFamily="34" charset="-120"/>
               </a:rPr>
-              <a:t>✚</a:t>
-            </a:r>
-            <a:endParaRPr lang="en-US" sz="3600" dirty="0"/>
-          </a:p>
-        </p:txBody>
-      </p:sp>
-      <p:sp>
-        <p:nvSpPr>
-          <p:cNvPr id="14" name="Text 12"/>
-          <p:cNvSpPr/>
-          <p:nvPr/>
-        </p:nvSpPr>
-        <p:spPr>
-          <a:xfrm>
-            <a:off x="884225" y="8869680"/>
-            <a:ext cx="2321357" cy="1097280"/>
-          </a:xfrm>
-          <a:prstGeom prst="rect">
-            <a:avLst/>
-          </a:prstGeom>
-          <a:noFill/>
-          <a:ln/>
-        </p:spPr>
-        <p:txBody>
-          <a:bodyPr wrap="square" rtlCol="0" anchor="ctr"/>
-          <a:lstStyle/>
+              <a:t>Médecins</a:t>
+            </a:r>
+            <a:endParaRPr lang="en-US" sz="2200" dirty="0"/>
+          </a:p>
           <a:p>
             <a:pPr algn="ctr" indent="0" marL="0">
               <a:buNone/>
@@ -4687,32 +4737,15 @@
                 <a:ea typeface="Sora" pitchFamily="34" charset="-122"/>
                 <a:cs typeface="Sora" pitchFamily="34" charset="-120"/>
               </a:rPr>
-              <a:t>Médecins</a:t>
+              <a:t>du travail</a:t>
             </a:r>
             <a:endParaRPr lang="en-US" sz="2200" dirty="0"/>
           </a:p>
-          <a:p>
-            <a:pPr algn="ctr" indent="0" marL="0">
-              <a:buNone/>
-            </a:pPr>
-            <a:r>
-              <a:rPr lang="en-US" sz="2200" b="1" dirty="0">
-                <a:solidFill>
-                  <a:srgbClr val="FFFFFF"/>
-                </a:solidFill>
-                <a:latin typeface="Sora" pitchFamily="34" charset="0"/>
-                <a:ea typeface="Sora" pitchFamily="34" charset="-122"/>
-                <a:cs typeface="Sora" pitchFamily="34" charset="-120"/>
-              </a:rPr>
-              <a:t>du travail</a:t>
-            </a:r>
-            <a:endParaRPr lang="en-US" sz="2200" dirty="0"/>
-          </a:p>
-        </p:txBody>
-      </p:sp>
-      <p:sp>
-        <p:nvSpPr>
-          <p:cNvPr id="15" name="Text 13"/>
+        </p:txBody>
+      </p:sp>
+      <p:sp>
+        <p:nvSpPr>
+          <p:cNvPr id="16" name="Text 14"/>
           <p:cNvSpPr/>
           <p:nvPr/>
         </p:nvSpPr>
@@ -4753,7 +4786,7 @@
       </p:sp>
       <p:sp>
         <p:nvSpPr>
-          <p:cNvPr id="16" name="Shape 14"/>
+          <p:cNvPr id="17" name="Shape 15"/>
           <p:cNvSpPr/>
           <p:nvPr/>
         </p:nvSpPr>
@@ -4784,7 +4817,7 @@
       </p:sp>
       <p:sp>
         <p:nvSpPr>
-          <p:cNvPr id="17" name="Shape 15"/>
+          <p:cNvPr id="18" name="Shape 16"/>
           <p:cNvSpPr/>
           <p:nvPr/>
         </p:nvSpPr>
@@ -4813,14 +4846,36 @@
       </p:sp>
       <p:sp>
         <p:nvSpPr>
-          <p:cNvPr id="18" name="Text 16"/>
-          <p:cNvSpPr/>
-          <p:nvPr/>
-        </p:nvSpPr>
-        <p:spPr>
-          <a:xfrm>
-            <a:off x="4549140" y="7498080"/>
-            <a:ext cx="1188720" cy="1005840"/>
+          <p:cNvPr id="19" name="Shape 17"/>
+          <p:cNvSpPr/>
+          <p:nvPr/>
+        </p:nvSpPr>
+        <p:spPr>
+          <a:xfrm>
+            <a:off x="4960620" y="7818120"/>
+            <a:ext cx="365760" cy="365760"/>
+          </a:xfrm>
+          <a:prstGeom prst="ellipse">
+            <a:avLst/>
+          </a:prstGeom>
+          <a:solidFill>
+            <a:srgbClr val="5EE7FF">
+              <a:alpha val="50000"/>
+            </a:srgbClr>
+          </a:solidFill>
+          <a:ln/>
+        </p:spPr>
+      </p:sp>
+      <p:sp>
+        <p:nvSpPr>
+          <p:cNvPr id="20" name="Text 18"/>
+          <p:cNvSpPr/>
+          <p:nvPr/>
+        </p:nvSpPr>
+        <p:spPr>
+          <a:xfrm>
+            <a:off x="3982822" y="8869680"/>
+            <a:ext cx="2321357" cy="1097280"/>
           </a:xfrm>
           <a:prstGeom prst="rect">
             <a:avLst/>
@@ -4836,40 +4891,18 @@
               <a:buNone/>
             </a:pPr>
             <a:r>
-              <a:rPr lang="en-US" sz="3600" b="1" dirty="0">
-                <a:solidFill>
-                  <a:srgbClr val="5EE7FF"/>
+              <a:rPr lang="en-US" sz="2200" b="1" dirty="0">
+                <a:solidFill>
+                  <a:srgbClr val="FFFFFF"/>
                 </a:solidFill>
                 <a:latin typeface="Sora" pitchFamily="34" charset="0"/>
                 <a:ea typeface="Sora" pitchFamily="34" charset="-122"/>
                 <a:cs typeface="Sora" pitchFamily="34" charset="-120"/>
               </a:rPr>
-              <a:t>◈</a:t>
-            </a:r>
-            <a:endParaRPr lang="en-US" sz="3600" dirty="0"/>
-          </a:p>
-        </p:txBody>
-      </p:sp>
-      <p:sp>
-        <p:nvSpPr>
-          <p:cNvPr id="19" name="Text 17"/>
-          <p:cNvSpPr/>
-          <p:nvPr/>
-        </p:nvSpPr>
-        <p:spPr>
-          <a:xfrm>
-            <a:off x="3982822" y="8869680"/>
-            <a:ext cx="2321357" cy="1097280"/>
-          </a:xfrm>
-          <a:prstGeom prst="rect">
-            <a:avLst/>
-          </a:prstGeom>
-          <a:noFill/>
-          <a:ln/>
-        </p:spPr>
-        <p:txBody>
-          <a:bodyPr wrap="square" rtlCol="0" anchor="ctr"/>
-          <a:lstStyle/>
+              <a:t>QHSE</a:t>
+            </a:r>
+            <a:endParaRPr lang="en-US" sz="2200" dirty="0"/>
+          </a:p>
           <a:p>
             <a:pPr algn="ctr" indent="0" marL="0">
               <a:buNone/>
@@ -4883,32 +4916,15 @@
                 <a:ea typeface="Sora" pitchFamily="34" charset="-122"/>
                 <a:cs typeface="Sora" pitchFamily="34" charset="-120"/>
               </a:rPr>
-              <a:t>QHSE</a:t>
+              <a:t>/ HSE</a:t>
             </a:r>
             <a:endParaRPr lang="en-US" sz="2200" dirty="0"/>
           </a:p>
-          <a:p>
-            <a:pPr algn="ctr" indent="0" marL="0">
-              <a:buNone/>
-            </a:pPr>
-            <a:r>
-              <a:rPr lang="en-US" sz="2200" b="1" dirty="0">
-                <a:solidFill>
-                  <a:srgbClr val="FFFFFF"/>
-                </a:solidFill>
-                <a:latin typeface="Sora" pitchFamily="34" charset="0"/>
-                <a:ea typeface="Sora" pitchFamily="34" charset="-122"/>
-                <a:cs typeface="Sora" pitchFamily="34" charset="-120"/>
-              </a:rPr>
-              <a:t>/ HSE</a:t>
-            </a:r>
-            <a:endParaRPr lang="en-US" sz="2200" dirty="0"/>
-          </a:p>
-        </p:txBody>
-      </p:sp>
-      <p:sp>
-        <p:nvSpPr>
-          <p:cNvPr id="20" name="Text 18"/>
+        </p:txBody>
+      </p:sp>
+      <p:sp>
+        <p:nvSpPr>
+          <p:cNvPr id="21" name="Text 19"/>
           <p:cNvSpPr/>
           <p:nvPr/>
         </p:nvSpPr>
@@ -4949,7 +4965,7 @@
       </p:sp>
       <p:sp>
         <p:nvSpPr>
-          <p:cNvPr id="21" name="Shape 19"/>
+          <p:cNvPr id="22" name="Shape 20"/>
           <p:cNvSpPr/>
           <p:nvPr/>
         </p:nvSpPr>
@@ -4980,7 +4996,7 @@
       </p:sp>
       <p:sp>
         <p:nvSpPr>
-          <p:cNvPr id="22" name="Shape 20"/>
+          <p:cNvPr id="23" name="Shape 21"/>
           <p:cNvSpPr/>
           <p:nvPr/>
         </p:nvSpPr>
@@ -5009,14 +5025,36 @@
       </p:sp>
       <p:sp>
         <p:nvSpPr>
-          <p:cNvPr id="23" name="Text 21"/>
-          <p:cNvSpPr/>
-          <p:nvPr/>
-        </p:nvSpPr>
-        <p:spPr>
-          <a:xfrm>
-            <a:off x="7647737" y="7498080"/>
-            <a:ext cx="1188720" cy="1005840"/>
+          <p:cNvPr id="24" name="Shape 22"/>
+          <p:cNvSpPr/>
+          <p:nvPr/>
+        </p:nvSpPr>
+        <p:spPr>
+          <a:xfrm>
+            <a:off x="8059217" y="7818120"/>
+            <a:ext cx="365760" cy="365760"/>
+          </a:xfrm>
+          <a:prstGeom prst="ellipse">
+            <a:avLst/>
+          </a:prstGeom>
+          <a:solidFill>
+            <a:srgbClr val="5EE7FF">
+              <a:alpha val="50000"/>
+            </a:srgbClr>
+          </a:solidFill>
+          <a:ln/>
+        </p:spPr>
+      </p:sp>
+      <p:sp>
+        <p:nvSpPr>
+          <p:cNvPr id="25" name="Text 23"/>
+          <p:cNvSpPr/>
+          <p:nvPr/>
+        </p:nvSpPr>
+        <p:spPr>
+          <a:xfrm>
+            <a:off x="7081418" y="8869680"/>
+            <a:ext cx="2321357" cy="1097280"/>
           </a:xfrm>
           <a:prstGeom prst="rect">
             <a:avLst/>
@@ -5032,40 +5070,18 @@
               <a:buNone/>
             </a:pPr>
             <a:r>
-              <a:rPr lang="en-US" sz="3600" b="1" dirty="0">
-                <a:solidFill>
-                  <a:srgbClr val="5EE7FF"/>
+              <a:rPr lang="en-US" sz="2200" b="1" dirty="0">
+                <a:solidFill>
+                  <a:srgbClr val="FFFFFF"/>
                 </a:solidFill>
                 <a:latin typeface="Sora" pitchFamily="34" charset="0"/>
                 <a:ea typeface="Sora" pitchFamily="34" charset="-122"/>
                 <a:cs typeface="Sora" pitchFamily="34" charset="-120"/>
               </a:rPr>
-              <a:t>◉</a:t>
-            </a:r>
-            <a:endParaRPr lang="en-US" sz="3600" dirty="0"/>
-          </a:p>
-        </p:txBody>
-      </p:sp>
-      <p:sp>
-        <p:nvSpPr>
-          <p:cNvPr id="24" name="Text 22"/>
-          <p:cNvSpPr/>
-          <p:nvPr/>
-        </p:nvSpPr>
-        <p:spPr>
-          <a:xfrm>
-            <a:off x="7081418" y="8869680"/>
-            <a:ext cx="2321357" cy="1097280"/>
-          </a:xfrm>
-          <a:prstGeom prst="rect">
-            <a:avLst/>
-          </a:prstGeom>
-          <a:noFill/>
-          <a:ln/>
-        </p:spPr>
-        <p:txBody>
-          <a:bodyPr wrap="square" rtlCol="0" anchor="ctr"/>
-          <a:lstStyle/>
+              <a:t>Ressources</a:t>
+            </a:r>
+            <a:endParaRPr lang="en-US" sz="2200" dirty="0"/>
+          </a:p>
           <a:p>
             <a:pPr algn="ctr" indent="0" marL="0">
               <a:buNone/>
@@ -5079,32 +5095,15 @@
                 <a:ea typeface="Sora" pitchFamily="34" charset="-122"/>
                 <a:cs typeface="Sora" pitchFamily="34" charset="-120"/>
               </a:rPr>
-              <a:t>Ressources</a:t>
+              <a:t>Humaines</a:t>
             </a:r>
             <a:endParaRPr lang="en-US" sz="2200" dirty="0"/>
           </a:p>
-          <a:p>
-            <a:pPr algn="ctr" indent="0" marL="0">
-              <a:buNone/>
-            </a:pPr>
-            <a:r>
-              <a:rPr lang="en-US" sz="2200" b="1" dirty="0">
-                <a:solidFill>
-                  <a:srgbClr val="FFFFFF"/>
-                </a:solidFill>
-                <a:latin typeface="Sora" pitchFamily="34" charset="0"/>
-                <a:ea typeface="Sora" pitchFamily="34" charset="-122"/>
-                <a:cs typeface="Sora" pitchFamily="34" charset="-120"/>
-              </a:rPr>
-              <a:t>Humaines</a:t>
-            </a:r>
-            <a:endParaRPr lang="en-US" sz="2200" dirty="0"/>
-          </a:p>
-        </p:txBody>
-      </p:sp>
-      <p:sp>
-        <p:nvSpPr>
-          <p:cNvPr id="25" name="Text 23"/>
+        </p:txBody>
+      </p:sp>
+      <p:sp>
+        <p:nvSpPr>
+          <p:cNvPr id="26" name="Text 24"/>
           <p:cNvSpPr/>
           <p:nvPr/>
         </p:nvSpPr>
@@ -5145,7 +5144,7 @@
       </p:sp>
       <p:sp>
         <p:nvSpPr>
-          <p:cNvPr id="26" name="Shape 24"/>
+          <p:cNvPr id="27" name="Shape 25"/>
           <p:cNvSpPr/>
           <p:nvPr/>
         </p:nvSpPr>
@@ -5174,7 +5173,7 @@
       </p:sp>
       <p:sp>
         <p:nvSpPr>
-          <p:cNvPr id="27" name="Text 25"/>
+          <p:cNvPr id="28" name="Text 26"/>
           <p:cNvSpPr/>
           <p:nvPr/>
         </p:nvSpPr>
@@ -5320,12 +5319,14 @@
             <a:off x="609905" y="566928"/>
             <a:ext cx="201168" cy="201168"/>
           </a:xfrm>
-          <a:prstGeom prst="rightTriangle">
-            <a:avLst/>
+          <a:prstGeom prst="roundRect">
+            <a:avLst>
+              <a:gd name="adj" fmla="val 18182"/>
+            </a:avLst>
           </a:prstGeom>
           <a:solidFill>
             <a:srgbClr val="5EE7FF">
-              <a:alpha val="20000"/>
+              <a:alpha val="40000"/>
             </a:srgbClr>
           </a:solidFill>
           <a:ln w="12700">
@@ -5406,9 +5407,9 @@
                     <a:alpha val="50000"/>
                   </a:srgbClr>
                 </a:solidFill>
-                <a:latin typeface="JetBrains Mono" pitchFamily="34" charset="0"/>
-                <a:ea typeface="JetBrains Mono" pitchFamily="34" charset="-122"/>
-                <a:cs typeface="JetBrains Mono" pitchFamily="34" charset="-120"/>
+                <a:latin typeface="Consolas" pitchFamily="34" charset="0"/>
+                <a:ea typeface="Consolas" pitchFamily="34" charset="-122"/>
+                <a:cs typeface="Consolas" pitchFamily="34" charset="-120"/>
               </a:rPr>
               <a:t>05 / 06</a:t>
             </a:r>
@@ -5505,10 +5506,32 @@
                 <a:ea typeface="Sora" pitchFamily="34" charset="-122"/>
                 <a:cs typeface="Sora" pitchFamily="34" charset="-120"/>
               </a:rPr>
-              <a:t>qu'un </a:t>
+              <a:t>qu'un outil.</a:t>
             </a:r>
             <a:endParaRPr lang="en-US" sz="4800" dirty="0"/>
           </a:p>
+        </p:txBody>
+      </p:sp>
+      <p:sp>
+        <p:nvSpPr>
+          <p:cNvPr id="10" name="Text 8"/>
+          <p:cNvSpPr/>
+          <p:nvPr/>
+        </p:nvSpPr>
+        <p:spPr>
+          <a:xfrm>
+            <a:off x="609905" y="3429000"/>
+            <a:ext cx="9067190" cy="914400"/>
+          </a:xfrm>
+          <a:prstGeom prst="rect">
+            <a:avLst/>
+          </a:prstGeom>
+          <a:noFill/>
+          <a:ln/>
+        </p:spPr>
+        <p:txBody>
+          <a:bodyPr wrap="square" rtlCol="0" anchor="ctr"/>
+          <a:lstStyle/>
           <a:p>
             <a:pPr algn="ctr" indent="0" marL="0">
               <a:buNone/>
@@ -5522,21 +5545,7 @@
                 <a:ea typeface="Sora" pitchFamily="34" charset="-122"/>
                 <a:cs typeface="Sora" pitchFamily="34" charset="-120"/>
               </a:rPr>
-              <a:t>outil</a:t>
-            </a:r>
-            <a:pPr algn="ctr" indent="0" marL="0">
-              <a:buNone/>
-            </a:pPr>
-            <a:r>
-              <a:rPr lang="en-US" sz="4800" b="1" dirty="0">
-                <a:solidFill>
-                  <a:srgbClr val="FFFFFF"/>
-                </a:solidFill>
-                <a:latin typeface="Sora" pitchFamily="34" charset="0"/>
-                <a:ea typeface="Sora" pitchFamily="34" charset="-122"/>
-                <a:cs typeface="Sora" pitchFamily="34" charset="-120"/>
-              </a:rPr>
-              <a:t>.</a:t>
+              <a:t>outil.</a:t>
             </a:r>
             <a:endParaRPr lang="en-US" sz="4800" dirty="0"/>
           </a:p>
@@ -5544,7 +5553,7 @@
       </p:sp>
       <p:sp>
         <p:nvSpPr>
-          <p:cNvPr id="10" name="Shape 8"/>
+          <p:cNvPr id="11" name="Shape 9"/>
           <p:cNvSpPr/>
           <p:nvPr/>
         </p:nvSpPr>
@@ -5564,23 +5573,23 @@
       </p:sp>
       <p:sp>
         <p:nvSpPr>
-          <p:cNvPr id="11" name="Shape 9"/>
-          <p:cNvSpPr/>
-          <p:nvPr/>
-        </p:nvSpPr>
-        <p:spPr>
-          <a:xfrm>
-            <a:off x="4031483" y="6766560"/>
-            <a:ext cx="240030" cy="240030"/>
+          <p:cNvPr id="12" name="Shape 10"/>
+          <p:cNvSpPr/>
+          <p:nvPr/>
+        </p:nvSpPr>
+        <p:spPr>
+          <a:xfrm>
+            <a:off x="3223260" y="6766560"/>
+            <a:ext cx="1920240" cy="1920240"/>
           </a:xfrm>
           <a:prstGeom prst="line">
             <a:avLst/>
           </a:prstGeom>
           <a:noFill/>
-          <a:ln w="6350">
+          <a:ln w="9525">
             <a:solidFill>
               <a:srgbClr val="5EE7FF">
-                <a:alpha val="40000"/>
+                <a:alpha val="35000"/>
               </a:srgbClr>
             </a:solidFill>
             <a:prstDash val="solid"/>
@@ -5589,23 +5598,23 @@
       </p:sp>
       <p:sp>
         <p:nvSpPr>
-          <p:cNvPr id="12" name="Shape 10"/>
-          <p:cNvSpPr/>
-          <p:nvPr/>
-        </p:nvSpPr>
-        <p:spPr>
-          <a:xfrm>
-            <a:off x="4511543" y="7246620"/>
-            <a:ext cx="240030" cy="240030"/>
+          <p:cNvPr id="13" name="Shape 11"/>
+          <p:cNvSpPr/>
+          <p:nvPr/>
+        </p:nvSpPr>
+        <p:spPr>
+          <a:xfrm>
+            <a:off x="7063740" y="6766560"/>
+            <a:ext cx="-1920240" cy="1920240"/>
           </a:xfrm>
           <a:prstGeom prst="line">
             <a:avLst/>
           </a:prstGeom>
           <a:noFill/>
-          <a:ln w="6350">
+          <a:ln w="9525">
             <a:solidFill>
               <a:srgbClr val="5EE7FF">
-                <a:alpha val="40000"/>
+                <a:alpha val="35000"/>
               </a:srgbClr>
             </a:solidFill>
             <a:prstDash val="solid"/>
@@ -5614,23 +5623,23 @@
       </p:sp>
       <p:sp>
         <p:nvSpPr>
-          <p:cNvPr id="13" name="Shape 11"/>
-          <p:cNvSpPr/>
-          <p:nvPr/>
-        </p:nvSpPr>
-        <p:spPr>
-          <a:xfrm>
-            <a:off x="4991603" y="7726680"/>
-            <a:ext cx="240030" cy="240030"/>
+          <p:cNvPr id="14" name="Shape 12"/>
+          <p:cNvSpPr/>
+          <p:nvPr/>
+        </p:nvSpPr>
+        <p:spPr>
+          <a:xfrm>
+            <a:off x="7063740" y="10607040"/>
+            <a:ext cx="-1920240" cy="-1920240"/>
           </a:xfrm>
           <a:prstGeom prst="line">
             <a:avLst/>
           </a:prstGeom>
           <a:noFill/>
-          <a:ln w="6350">
+          <a:ln w="9525">
             <a:solidFill>
               <a:srgbClr val="5EE7FF">
-                <a:alpha val="40000"/>
+                <a:alpha val="35000"/>
               </a:srgbClr>
             </a:solidFill>
             <a:prstDash val="solid"/>
@@ -5639,23 +5648,23 @@
       </p:sp>
       <p:sp>
         <p:nvSpPr>
-          <p:cNvPr id="14" name="Shape 12"/>
-          <p:cNvSpPr/>
-          <p:nvPr/>
-        </p:nvSpPr>
-        <p:spPr>
-          <a:xfrm>
-            <a:off x="5471663" y="8206740"/>
-            <a:ext cx="240030" cy="240030"/>
+          <p:cNvPr id="15" name="Shape 13"/>
+          <p:cNvSpPr/>
+          <p:nvPr/>
+        </p:nvSpPr>
+        <p:spPr>
+          <a:xfrm>
+            <a:off x="3223260" y="10607040"/>
+            <a:ext cx="1920240" cy="-1920240"/>
           </a:xfrm>
           <a:prstGeom prst="line">
             <a:avLst/>
           </a:prstGeom>
           <a:noFill/>
-          <a:ln w="6350">
+          <a:ln w="9525">
             <a:solidFill>
               <a:srgbClr val="5EE7FF">
-                <a:alpha val="40000"/>
+                <a:alpha val="35000"/>
               </a:srgbClr>
             </a:solidFill>
             <a:prstDash val="solid"/>
@@ -5664,307 +5673,7 @@
       </p:sp>
       <p:sp>
         <p:nvSpPr>
-          <p:cNvPr id="15" name="Shape 13"/>
-          <p:cNvSpPr/>
-          <p:nvPr/>
-        </p:nvSpPr>
-        <p:spPr>
-          <a:xfrm>
-            <a:off x="6255517" y="6766560"/>
-            <a:ext cx="-240030" cy="240030"/>
-          </a:xfrm>
-          <a:prstGeom prst="line">
-            <a:avLst/>
-          </a:prstGeom>
-          <a:noFill/>
-          <a:ln w="6350">
-            <a:solidFill>
-              <a:srgbClr val="5EE7FF">
-                <a:alpha val="40000"/>
-              </a:srgbClr>
-            </a:solidFill>
-            <a:prstDash val="solid"/>
-          </a:ln>
-        </p:spPr>
-      </p:sp>
-      <p:sp>
-        <p:nvSpPr>
           <p:cNvPr id="16" name="Shape 14"/>
-          <p:cNvSpPr/>
-          <p:nvPr/>
-        </p:nvSpPr>
-        <p:spPr>
-          <a:xfrm>
-            <a:off x="5775457" y="7246620"/>
-            <a:ext cx="-240030" cy="240030"/>
-          </a:xfrm>
-          <a:prstGeom prst="line">
-            <a:avLst/>
-          </a:prstGeom>
-          <a:noFill/>
-          <a:ln w="6350">
-            <a:solidFill>
-              <a:srgbClr val="5EE7FF">
-                <a:alpha val="40000"/>
-              </a:srgbClr>
-            </a:solidFill>
-            <a:prstDash val="solid"/>
-          </a:ln>
-        </p:spPr>
-      </p:sp>
-      <p:sp>
-        <p:nvSpPr>
-          <p:cNvPr id="17" name="Shape 15"/>
-          <p:cNvSpPr/>
-          <p:nvPr/>
-        </p:nvSpPr>
-        <p:spPr>
-          <a:xfrm>
-            <a:off x="5295397" y="7726680"/>
-            <a:ext cx="-240030" cy="240030"/>
-          </a:xfrm>
-          <a:prstGeom prst="line">
-            <a:avLst/>
-          </a:prstGeom>
-          <a:noFill/>
-          <a:ln w="6350">
-            <a:solidFill>
-              <a:srgbClr val="5EE7FF">
-                <a:alpha val="40000"/>
-              </a:srgbClr>
-            </a:solidFill>
-            <a:prstDash val="solid"/>
-          </a:ln>
-        </p:spPr>
-      </p:sp>
-      <p:sp>
-        <p:nvSpPr>
-          <p:cNvPr id="18" name="Shape 16"/>
-          <p:cNvSpPr/>
-          <p:nvPr/>
-        </p:nvSpPr>
-        <p:spPr>
-          <a:xfrm>
-            <a:off x="4815337" y="8206740"/>
-            <a:ext cx="-240030" cy="240030"/>
-          </a:xfrm>
-          <a:prstGeom prst="line">
-            <a:avLst/>
-          </a:prstGeom>
-          <a:noFill/>
-          <a:ln w="6350">
-            <a:solidFill>
-              <a:srgbClr val="5EE7FF">
-                <a:alpha val="40000"/>
-              </a:srgbClr>
-            </a:solidFill>
-            <a:prstDash val="solid"/>
-          </a:ln>
-        </p:spPr>
-      </p:sp>
-      <p:sp>
-        <p:nvSpPr>
-          <p:cNvPr id="19" name="Shape 17"/>
-          <p:cNvSpPr/>
-          <p:nvPr/>
-        </p:nvSpPr>
-        <p:spPr>
-          <a:xfrm>
-            <a:off x="6255517" y="10607040"/>
-            <a:ext cx="-240030" cy="-240030"/>
-          </a:xfrm>
-          <a:prstGeom prst="line">
-            <a:avLst/>
-          </a:prstGeom>
-          <a:noFill/>
-          <a:ln w="6350">
-            <a:solidFill>
-              <a:srgbClr val="5EE7FF">
-                <a:alpha val="40000"/>
-              </a:srgbClr>
-            </a:solidFill>
-            <a:prstDash val="solid"/>
-          </a:ln>
-        </p:spPr>
-      </p:sp>
-      <p:sp>
-        <p:nvSpPr>
-          <p:cNvPr id="20" name="Shape 18"/>
-          <p:cNvSpPr/>
-          <p:nvPr/>
-        </p:nvSpPr>
-        <p:spPr>
-          <a:xfrm>
-            <a:off x="5775457" y="10126980"/>
-            <a:ext cx="-240030" cy="-240030"/>
-          </a:xfrm>
-          <a:prstGeom prst="line">
-            <a:avLst/>
-          </a:prstGeom>
-          <a:noFill/>
-          <a:ln w="6350">
-            <a:solidFill>
-              <a:srgbClr val="5EE7FF">
-                <a:alpha val="40000"/>
-              </a:srgbClr>
-            </a:solidFill>
-            <a:prstDash val="solid"/>
-          </a:ln>
-        </p:spPr>
-      </p:sp>
-      <p:sp>
-        <p:nvSpPr>
-          <p:cNvPr id="21" name="Shape 19"/>
-          <p:cNvSpPr/>
-          <p:nvPr/>
-        </p:nvSpPr>
-        <p:spPr>
-          <a:xfrm>
-            <a:off x="5295397" y="9646920"/>
-            <a:ext cx="-240030" cy="-240030"/>
-          </a:xfrm>
-          <a:prstGeom prst="line">
-            <a:avLst/>
-          </a:prstGeom>
-          <a:noFill/>
-          <a:ln w="6350">
-            <a:solidFill>
-              <a:srgbClr val="5EE7FF">
-                <a:alpha val="40000"/>
-              </a:srgbClr>
-            </a:solidFill>
-            <a:prstDash val="solid"/>
-          </a:ln>
-        </p:spPr>
-      </p:sp>
-      <p:sp>
-        <p:nvSpPr>
-          <p:cNvPr id="22" name="Shape 20"/>
-          <p:cNvSpPr/>
-          <p:nvPr/>
-        </p:nvSpPr>
-        <p:spPr>
-          <a:xfrm>
-            <a:off x="4815337" y="9166860"/>
-            <a:ext cx="-240030" cy="-240030"/>
-          </a:xfrm>
-          <a:prstGeom prst="line">
-            <a:avLst/>
-          </a:prstGeom>
-          <a:noFill/>
-          <a:ln w="6350">
-            <a:solidFill>
-              <a:srgbClr val="5EE7FF">
-                <a:alpha val="40000"/>
-              </a:srgbClr>
-            </a:solidFill>
-            <a:prstDash val="solid"/>
-          </a:ln>
-        </p:spPr>
-      </p:sp>
-      <p:sp>
-        <p:nvSpPr>
-          <p:cNvPr id="23" name="Shape 21"/>
-          <p:cNvSpPr/>
-          <p:nvPr/>
-        </p:nvSpPr>
-        <p:spPr>
-          <a:xfrm>
-            <a:off x="4031483" y="10607040"/>
-            <a:ext cx="240030" cy="-240030"/>
-          </a:xfrm>
-          <a:prstGeom prst="line">
-            <a:avLst/>
-          </a:prstGeom>
-          <a:noFill/>
-          <a:ln w="6350">
-            <a:solidFill>
-              <a:srgbClr val="5EE7FF">
-                <a:alpha val="40000"/>
-              </a:srgbClr>
-            </a:solidFill>
-            <a:prstDash val="solid"/>
-          </a:ln>
-        </p:spPr>
-      </p:sp>
-      <p:sp>
-        <p:nvSpPr>
-          <p:cNvPr id="24" name="Shape 22"/>
-          <p:cNvSpPr/>
-          <p:nvPr/>
-        </p:nvSpPr>
-        <p:spPr>
-          <a:xfrm>
-            <a:off x="4511543" y="10126980"/>
-            <a:ext cx="240030" cy="-240030"/>
-          </a:xfrm>
-          <a:prstGeom prst="line">
-            <a:avLst/>
-          </a:prstGeom>
-          <a:noFill/>
-          <a:ln w="6350">
-            <a:solidFill>
-              <a:srgbClr val="5EE7FF">
-                <a:alpha val="40000"/>
-              </a:srgbClr>
-            </a:solidFill>
-            <a:prstDash val="solid"/>
-          </a:ln>
-        </p:spPr>
-      </p:sp>
-      <p:sp>
-        <p:nvSpPr>
-          <p:cNvPr id="25" name="Shape 23"/>
-          <p:cNvSpPr/>
-          <p:nvPr/>
-        </p:nvSpPr>
-        <p:spPr>
-          <a:xfrm>
-            <a:off x="4991603" y="9646920"/>
-            <a:ext cx="240030" cy="-240030"/>
-          </a:xfrm>
-          <a:prstGeom prst="line">
-            <a:avLst/>
-          </a:prstGeom>
-          <a:noFill/>
-          <a:ln w="6350">
-            <a:solidFill>
-              <a:srgbClr val="5EE7FF">
-                <a:alpha val="40000"/>
-              </a:srgbClr>
-            </a:solidFill>
-            <a:prstDash val="solid"/>
-          </a:ln>
-        </p:spPr>
-      </p:sp>
-      <p:sp>
-        <p:nvSpPr>
-          <p:cNvPr id="26" name="Shape 24"/>
-          <p:cNvSpPr/>
-          <p:nvPr/>
-        </p:nvSpPr>
-        <p:spPr>
-          <a:xfrm>
-            <a:off x="5471663" y="9166860"/>
-            <a:ext cx="240030" cy="-240030"/>
-          </a:xfrm>
-          <a:prstGeom prst="line">
-            <a:avLst/>
-          </a:prstGeom>
-          <a:noFill/>
-          <a:ln w="6350">
-            <a:solidFill>
-              <a:srgbClr val="5EE7FF">
-                <a:alpha val="40000"/>
-              </a:srgbClr>
-            </a:solidFill>
-            <a:prstDash val="solid"/>
-          </a:ln>
-        </p:spPr>
-      </p:sp>
-      <p:sp>
-        <p:nvSpPr>
-          <p:cNvPr id="27" name="Shape 25"/>
           <p:cNvSpPr/>
           <p:nvPr/>
         </p:nvSpPr>
@@ -5993,7 +5702,7 @@
       </p:sp>
       <p:sp>
         <p:nvSpPr>
-          <p:cNvPr id="28" name="Text 26"/>
+          <p:cNvPr id="17" name="Text 15"/>
           <p:cNvSpPr/>
           <p:nvPr/>
         </p:nvSpPr>
@@ -6020,9 +5729,9 @@
                 <a:solidFill>
                   <a:srgbClr val="5EE7FF"/>
                 </a:solidFill>
-                <a:latin typeface="JetBrains Mono" pitchFamily="34" charset="0"/>
-                <a:ea typeface="JetBrains Mono" pitchFamily="34" charset="-122"/>
-                <a:cs typeface="JetBrains Mono" pitchFamily="34" charset="-120"/>
+                <a:latin typeface="Consolas" pitchFamily="34" charset="0"/>
+                <a:ea typeface="Consolas" pitchFamily="34" charset="-122"/>
+                <a:cs typeface="Consolas" pitchFamily="34" charset="-120"/>
               </a:rPr>
               <a:t>01</a:t>
             </a:r>
@@ -6032,7 +5741,7 @@
       </p:sp>
       <p:sp>
         <p:nvSpPr>
-          <p:cNvPr id="29" name="Text 27"/>
+          <p:cNvPr id="18" name="Text 16"/>
           <p:cNvSpPr/>
           <p:nvPr/>
         </p:nvSpPr>
@@ -6071,7 +5780,7 @@
       </p:sp>
       <p:sp>
         <p:nvSpPr>
-          <p:cNvPr id="30" name="Shape 28"/>
+          <p:cNvPr id="19" name="Shape 17"/>
           <p:cNvSpPr/>
           <p:nvPr/>
         </p:nvSpPr>
@@ -6100,7 +5809,7 @@
       </p:sp>
       <p:sp>
         <p:nvSpPr>
-          <p:cNvPr id="31" name="Text 29"/>
+          <p:cNvPr id="20" name="Text 18"/>
           <p:cNvSpPr/>
           <p:nvPr/>
         </p:nvSpPr>
@@ -6127,9 +5836,9 @@
                 <a:solidFill>
                   <a:srgbClr val="5EE7FF"/>
                 </a:solidFill>
-                <a:latin typeface="JetBrains Mono" pitchFamily="34" charset="0"/>
-                <a:ea typeface="JetBrains Mono" pitchFamily="34" charset="-122"/>
-                <a:cs typeface="JetBrains Mono" pitchFamily="34" charset="-120"/>
+                <a:latin typeface="Consolas" pitchFamily="34" charset="0"/>
+                <a:ea typeface="Consolas" pitchFamily="34" charset="-122"/>
+                <a:cs typeface="Consolas" pitchFamily="34" charset="-120"/>
               </a:rPr>
               <a:t>02</a:t>
             </a:r>
@@ -6139,7 +5848,7 @@
       </p:sp>
       <p:sp>
         <p:nvSpPr>
-          <p:cNvPr id="32" name="Text 30"/>
+          <p:cNvPr id="21" name="Text 19"/>
           <p:cNvSpPr/>
           <p:nvPr/>
         </p:nvSpPr>
@@ -6178,7 +5887,7 @@
       </p:sp>
       <p:sp>
         <p:nvSpPr>
-          <p:cNvPr id="33" name="Shape 31"/>
+          <p:cNvPr id="22" name="Shape 20"/>
           <p:cNvSpPr/>
           <p:nvPr/>
         </p:nvSpPr>
@@ -6207,7 +5916,7 @@
       </p:sp>
       <p:sp>
         <p:nvSpPr>
-          <p:cNvPr id="34" name="Text 32"/>
+          <p:cNvPr id="23" name="Text 21"/>
           <p:cNvSpPr/>
           <p:nvPr/>
         </p:nvSpPr>
@@ -6234,9 +5943,9 @@
                 <a:solidFill>
                   <a:srgbClr val="5EE7FF"/>
                 </a:solidFill>
-                <a:latin typeface="JetBrains Mono" pitchFamily="34" charset="0"/>
-                <a:ea typeface="JetBrains Mono" pitchFamily="34" charset="-122"/>
-                <a:cs typeface="JetBrains Mono" pitchFamily="34" charset="-120"/>
+                <a:latin typeface="Consolas" pitchFamily="34" charset="0"/>
+                <a:ea typeface="Consolas" pitchFamily="34" charset="-122"/>
+                <a:cs typeface="Consolas" pitchFamily="34" charset="-120"/>
               </a:rPr>
               <a:t>03</a:t>
             </a:r>
@@ -6246,7 +5955,7 @@
       </p:sp>
       <p:sp>
         <p:nvSpPr>
-          <p:cNvPr id="35" name="Text 33"/>
+          <p:cNvPr id="24" name="Text 22"/>
           <p:cNvSpPr/>
           <p:nvPr/>
         </p:nvSpPr>
@@ -6285,7 +5994,7 @@
       </p:sp>
       <p:sp>
         <p:nvSpPr>
-          <p:cNvPr id="36" name="Shape 34"/>
+          <p:cNvPr id="25" name="Shape 23"/>
           <p:cNvSpPr/>
           <p:nvPr/>
         </p:nvSpPr>
@@ -6314,7 +6023,7 @@
       </p:sp>
       <p:sp>
         <p:nvSpPr>
-          <p:cNvPr id="37" name="Text 35"/>
+          <p:cNvPr id="26" name="Text 24"/>
           <p:cNvSpPr/>
           <p:nvPr/>
         </p:nvSpPr>
@@ -6341,9 +6050,9 @@
                 <a:solidFill>
                   <a:srgbClr val="5EE7FF"/>
                 </a:solidFill>
-                <a:latin typeface="JetBrains Mono" pitchFamily="34" charset="0"/>
-                <a:ea typeface="JetBrains Mono" pitchFamily="34" charset="-122"/>
-                <a:cs typeface="JetBrains Mono" pitchFamily="34" charset="-120"/>
+                <a:latin typeface="Consolas" pitchFamily="34" charset="0"/>
+                <a:ea typeface="Consolas" pitchFamily="34" charset="-122"/>
+                <a:cs typeface="Consolas" pitchFamily="34" charset="-120"/>
               </a:rPr>
               <a:t>04</a:t>
             </a:r>
@@ -6353,7 +6062,7 @@
       </p:sp>
       <p:sp>
         <p:nvSpPr>
-          <p:cNvPr id="38" name="Text 36"/>
+          <p:cNvPr id="27" name="Text 25"/>
           <p:cNvSpPr/>
           <p:nvPr/>
         </p:nvSpPr>
@@ -6392,7 +6101,7 @@
       </p:sp>
       <p:sp>
         <p:nvSpPr>
-          <p:cNvPr id="39" name="Shape 37"/>
+          <p:cNvPr id="28" name="Shape 26"/>
           <p:cNvSpPr/>
           <p:nvPr/>
         </p:nvSpPr>
@@ -6421,32 +6130,27 @@
       </p:sp>
       <p:sp>
         <p:nvSpPr>
-          <p:cNvPr id="40" name="Shape 38"/>
-          <p:cNvSpPr/>
-          <p:nvPr/>
-        </p:nvSpPr>
-        <p:spPr>
-          <a:xfrm>
-            <a:off x="4978908" y="8485632"/>
+          <p:cNvPr id="29" name="Shape 27"/>
+          <p:cNvSpPr/>
+          <p:nvPr/>
+        </p:nvSpPr>
+        <p:spPr>
+          <a:xfrm>
+            <a:off x="4978908" y="8522208"/>
             <a:ext cx="329184" cy="329184"/>
           </a:xfrm>
-          <a:prstGeom prst="rightTriangle">
+          <a:prstGeom prst="ellipse">
             <a:avLst/>
           </a:prstGeom>
           <a:solidFill>
             <a:srgbClr val="FFFFFF"/>
           </a:solidFill>
-          <a:ln w="12700">
-            <a:solidFill>
-              <a:srgbClr val="FFFFFF"/>
-            </a:solidFill>
-            <a:prstDash val="solid"/>
-          </a:ln>
-        </p:spPr>
-      </p:sp>
-      <p:sp>
-        <p:nvSpPr>
-          <p:cNvPr id="41" name="Shape 39"/>
+          <a:ln/>
+        </p:spPr>
+      </p:sp>
+      <p:sp>
+        <p:nvSpPr>
+          <p:cNvPr id="30" name="Shape 28"/>
           <p:cNvSpPr/>
           <p:nvPr/>
         </p:nvSpPr>
@@ -6475,7 +6179,7 @@
       </p:sp>
       <p:sp>
         <p:nvSpPr>
-          <p:cNvPr id="42" name="Text 40"/>
+          <p:cNvPr id="31" name="Text 29"/>
           <p:cNvSpPr/>
           <p:nvPr/>
         </p:nvSpPr>
@@ -6621,12 +6325,14 @@
             <a:off x="609905" y="566928"/>
             <a:ext cx="201168" cy="201168"/>
           </a:xfrm>
-          <a:prstGeom prst="rightTriangle">
-            <a:avLst/>
+          <a:prstGeom prst="roundRect">
+            <a:avLst>
+              <a:gd name="adj" fmla="val 18182"/>
+            </a:avLst>
           </a:prstGeom>
           <a:solidFill>
             <a:srgbClr val="5EE7FF">
-              <a:alpha val="20000"/>
+              <a:alpha val="40000"/>
             </a:srgbClr>
           </a:solidFill>
           <a:ln w="12700">
@@ -6707,9 +6413,9 @@
                     <a:alpha val="50000"/>
                   </a:srgbClr>
                 </a:solidFill>
-                <a:latin typeface="JetBrains Mono" pitchFamily="34" charset="0"/>
-                <a:ea typeface="JetBrains Mono" pitchFamily="34" charset="-122"/>
-                <a:cs typeface="JetBrains Mono" pitchFamily="34" charset="-120"/>
+                <a:latin typeface="Consolas" pitchFamily="34" charset="0"/>
+                <a:ea typeface="Consolas" pitchFamily="34" charset="-122"/>
+                <a:cs typeface="Consolas" pitchFamily="34" charset="-120"/>
               </a:rPr>
               <a:t>06 / 06</a:t>
             </a:r>
@@ -6826,10 +6532,32 @@
                 <a:ea typeface="Sora" pitchFamily="34" charset="-122"/>
                 <a:cs typeface="Sora" pitchFamily="34" charset="-120"/>
               </a:rPr>
-              <a:t>en </a:t>
+              <a:t>en action.</a:t>
             </a:r>
             <a:endParaRPr lang="en-US" sz="4800" dirty="0"/>
           </a:p>
+        </p:txBody>
+      </p:sp>
+      <p:sp>
+        <p:nvSpPr>
+          <p:cNvPr id="11" name="Text 9"/>
+          <p:cNvSpPr/>
+          <p:nvPr/>
+        </p:nvSpPr>
+        <p:spPr>
+          <a:xfrm>
+            <a:off x="1890065" y="3429000"/>
+            <a:ext cx="4572000" cy="914400"/>
+          </a:xfrm>
+          <a:prstGeom prst="rect">
+            <a:avLst/>
+          </a:prstGeom>
+          <a:noFill/>
+          <a:ln/>
+        </p:spPr>
+        <p:txBody>
+          <a:bodyPr wrap="square" rtlCol="0" anchor="ctr"/>
+          <a:lstStyle/>
           <a:p>
             <a:pPr indent="0" marL="0">
               <a:buNone/>
@@ -6843,21 +6571,7 @@
                 <a:ea typeface="Sora" pitchFamily="34" charset="-122"/>
                 <a:cs typeface="Sora" pitchFamily="34" charset="-120"/>
               </a:rPr>
-              <a:t>action</a:t>
-            </a:r>
-            <a:pPr indent="0" marL="0">
-              <a:buNone/>
-            </a:pPr>
-            <a:r>
-              <a:rPr lang="en-US" sz="4800" b="1" dirty="0">
-                <a:solidFill>
-                  <a:srgbClr val="FFFFFF"/>
-                </a:solidFill>
-                <a:latin typeface="Sora" pitchFamily="34" charset="0"/>
-                <a:ea typeface="Sora" pitchFamily="34" charset="-122"/>
-                <a:cs typeface="Sora" pitchFamily="34" charset="-120"/>
-              </a:rPr>
-              <a:t>.</a:t>
+              <a:t>action.</a:t>
             </a:r>
             <a:endParaRPr lang="en-US" sz="4800" dirty="0"/>
           </a:p>
@@ -6865,7 +6579,7 @@
       </p:sp>
       <p:sp>
         <p:nvSpPr>
-          <p:cNvPr id="11" name="Shape 9"/>
+          <p:cNvPr id="12" name="Shape 10"/>
           <p:cNvSpPr/>
           <p:nvPr/>
         </p:nvSpPr>
@@ -6885,7 +6599,7 @@
       </p:sp>
       <p:sp>
         <p:nvSpPr>
-          <p:cNvPr id="12" name="Shape 10"/>
+          <p:cNvPr id="13" name="Shape 11"/>
           <p:cNvSpPr/>
           <p:nvPr/>
         </p:nvSpPr>
@@ -6916,7 +6630,7 @@
       </p:sp>
       <p:sp>
         <p:nvSpPr>
-          <p:cNvPr id="13" name="Shape 11"/>
+          <p:cNvPr id="14" name="Shape 12"/>
           <p:cNvSpPr/>
           <p:nvPr/>
         </p:nvSpPr>
@@ -6945,42 +6659,6 @@
       </p:sp>
       <p:sp>
         <p:nvSpPr>
-          <p:cNvPr id="14" name="Text 12"/>
-          <p:cNvSpPr/>
-          <p:nvPr/>
-        </p:nvSpPr>
-        <p:spPr>
-          <a:xfrm>
-            <a:off x="1067105" y="5669280"/>
-            <a:ext cx="411480" cy="502920"/>
-          </a:xfrm>
-          <a:prstGeom prst="rect">
-            <a:avLst/>
-          </a:prstGeom>
-          <a:noFill/>
-          <a:ln/>
-        </p:spPr>
-        <p:txBody>
-          <a:bodyPr wrap="square" rtlCol="0" anchor="ctr"/>
-          <a:lstStyle/>
-          <a:p>
-            <a:pPr algn="ctr" indent="0" marL="0">
-              <a:buNone/>
-            </a:pPr>
-            <a:r>
-              <a:rPr lang="en-US" sz="1800" dirty="0">
-                <a:solidFill>
-                  <a:srgbClr val="000000"/>
-                </a:solidFill>
-              </a:rPr>
-              <a:t>📅</a:t>
-            </a:r>
-            <a:endParaRPr lang="en-US" sz="1800" dirty="0"/>
-          </a:p>
-        </p:txBody>
-      </p:sp>
-      <p:sp>
-        <p:nvSpPr>
           <p:cNvPr id="15" name="Text 13"/>
           <p:cNvSpPr/>
           <p:nvPr/>
@@ -7053,42 +6731,6 @@
         </p:nvSpPr>
         <p:spPr>
           <a:xfrm>
-            <a:off x="1067105" y="6355080"/>
-            <a:ext cx="411480" cy="502920"/>
-          </a:xfrm>
-          <a:prstGeom prst="rect">
-            <a:avLst/>
-          </a:prstGeom>
-          <a:noFill/>
-          <a:ln/>
-        </p:spPr>
-        <p:txBody>
-          <a:bodyPr wrap="square" rtlCol="0" anchor="ctr"/>
-          <a:lstStyle/>
-          <a:p>
-            <a:pPr algn="ctr" indent="0" marL="0">
-              <a:buNone/>
-            </a:pPr>
-            <a:r>
-              <a:rPr lang="en-US" sz="1800" dirty="0">
-                <a:solidFill>
-                  <a:srgbClr val="000000"/>
-                </a:solidFill>
-              </a:rPr>
-              <a:t>🎯</a:t>
-            </a:r>
-            <a:endParaRPr lang="en-US" sz="1800" dirty="0"/>
-          </a:p>
-        </p:txBody>
-      </p:sp>
-      <p:sp>
-        <p:nvSpPr>
-          <p:cNvPr id="18" name="Text 16"/>
-          <p:cNvSpPr/>
-          <p:nvPr/>
-        </p:nvSpPr>
-        <p:spPr>
-          <a:xfrm>
             <a:off x="1661465" y="6400800"/>
             <a:ext cx="7695590" cy="502920"/>
           </a:xfrm>
@@ -7122,7 +6764,7 @@
       </p:sp>
       <p:sp>
         <p:nvSpPr>
-          <p:cNvPr id="19" name="Shape 17"/>
+          <p:cNvPr id="18" name="Shape 16"/>
           <p:cNvSpPr/>
           <p:nvPr/>
         </p:nvSpPr>
@@ -7144,7 +6786,7 @@
       </p:sp>
       <p:sp>
         <p:nvSpPr>
-          <p:cNvPr id="20" name="Text 18"/>
+          <p:cNvPr id="19" name="Text 17"/>
           <p:cNvSpPr/>
           <p:nvPr/>
         </p:nvSpPr>
@@ -7183,7 +6825,7 @@
       </p:sp>
       <p:sp>
         <p:nvSpPr>
-          <p:cNvPr id="21" name="Shape 19"/>
+          <p:cNvPr id="20" name="Shape 18"/>
           <p:cNvSpPr/>
           <p:nvPr/>
         </p:nvSpPr>
@@ -7205,7 +6847,7 @@
       </p:sp>
       <p:sp>
         <p:nvSpPr>
-          <p:cNvPr id="22" name="Text 20"/>
+          <p:cNvPr id="21" name="Text 19"/>
           <p:cNvSpPr/>
           <p:nvPr/>
         </p:nvSpPr>
@@ -7232,9 +6874,9 @@
                 <a:solidFill>
                   <a:srgbClr val="082C78"/>
                 </a:solidFill>
-                <a:latin typeface="JetBrains Mono" pitchFamily="34" charset="0"/>
-                <a:ea typeface="JetBrains Mono" pitchFamily="34" charset="-122"/>
-                <a:cs typeface="JetBrains Mono" pitchFamily="34" charset="-120"/>
+                <a:latin typeface="Consolas" pitchFamily="34" charset="0"/>
+                <a:ea typeface="Consolas" pitchFamily="34" charset="-122"/>
+                <a:cs typeface="Consolas" pitchFamily="34" charset="-120"/>
               </a:rPr>
               <a:t>QR</a:t>
             </a:r>
@@ -7244,7 +6886,7 @@
       </p:sp>
       <p:sp>
         <p:nvSpPr>
-          <p:cNvPr id="23" name="Shape 21"/>
+          <p:cNvPr id="22" name="Shape 20"/>
           <p:cNvSpPr/>
           <p:nvPr/>
         </p:nvSpPr>
@@ -7264,7 +6906,7 @@
       </p:sp>
       <p:sp>
         <p:nvSpPr>
-          <p:cNvPr id="24" name="Text 22"/>
+          <p:cNvPr id="23" name="Text 21"/>
           <p:cNvSpPr/>
           <p:nvPr/>
         </p:nvSpPr>
@@ -7295,7 +6937,7 @@
                 <a:ea typeface="Inter" pitchFamily="34" charset="-122"/>
                 <a:cs typeface="Inter" pitchFamily="34" charset="-120"/>
               </a:rPr>
-              <a:t>www.normsafety.com   ·   contact@normsafety.com   ·   +216 54 525 267</a:t>
+              <a:t>www.normsafety.com   |   contact@normsafety.com   |   +216 54 525 267</a:t>
             </a:r>
             <a:endParaRPr lang="en-US" sz="1200" dirty="0"/>
           </a:p>

</xml_diff>